<commit_message>
M10: Monte Carlo and staged-entry real option; deck/README updated to match
Co-Authored-By: Claude Sonnet 5.5 <noreply@anthropic.com>
</commit_message>
<xml_diff>
--- a/outputs/deck/AssetLens_Board_Pack.pptx
+++ b/outputs/deck/AssetLens_Board_Pack.pptx
@@ -3262,7 +3262,7 @@
               </a:defRPr>
             </a:pPr>
             <a:r>
-              <a:t>• GCC private wealth office: illustrative NPV $184m, but 93% comes from terminal value (explicit-period NPV $14m): a staged entry is advisable.</a:t>
+              <a:t>• GCC private wealth office: illustrative NPV $184m, but 93% comes from terminal value (explicit-period NPV $14m): Monte Carlo: mean NPV $275m, 9% chance of loss; staging a pilot first was worth $-94m (negative: it delays a project that is positive in most paths).</a:t>
             </a:r>
           </a:p>
         </p:txBody>
@@ -4063,7 +4063,37 @@
               </a:defRPr>
             </a:pPr>
             <a:r>
-              <a:t>• Recommendation: conditional go, staged entry (representative office first), gated on advisor AUM ramp at year 2.</a:t>
+              <a:t>• Monte Carlo (1,000 paths): mean NPV $275m (P10 $6m, P90 $619m), 9% chance of loss.</a:t>
+            </a:r>
+          </a:p>
+          <a:p>
+            <a:pPr>
+              <a:spcAft>
+                <a:spcPts val="500"/>
+              </a:spcAft>
+              <a:defRPr sz="1300" b="0">
+                <a:solidFill>
+                  <a:srgbClr val="0B0B0B"/>
+                </a:solidFill>
+              </a:defRPr>
+            </a:pPr>
+            <a:r>
+              <a:t>• Staged entry (pilot, expand if AUM clears $350m at year 2; 52% pass): option value $-94m, i.e. staging lowers expected value; use it only as risk control.</a:t>
+            </a:r>
+          </a:p>
+          <a:p>
+            <a:pPr>
+              <a:spcAft>
+                <a:spcPts val="500"/>
+              </a:spcAft>
+              <a:defRPr sz="1300" b="0">
+                <a:solidFill>
+                  <a:srgbClr val="0B0B0B"/>
+                </a:solidFill>
+              </a:defRPr>
+            </a:pPr>
+            <a:r>
+              <a:t>• Recommendation: conditional go on the full plan, gated on validating AUM per advisor and net revenue bps; the explicit-period NPV is small so the case rests on terminal value.</a:t>
             </a:r>
           </a:p>
           <a:p>

</xml_diff>

<commit_message>
Deck PDF renderer with overflow check, chart label de-collision, 7-peer slide text, money formatting
Co-Authored-By: Claude Sonnet 5.5 <noreply@anthropic.com>
</commit_message>
<xml_diff>
--- a/outputs/deck/AssetLens_Board_Pack.pptx
+++ b/outputs/deck/AssetLens_Board_Pack.pptx
@@ -3126,7 +3126,7 @@
               </a:defRPr>
             </a:pPr>
             <a:r>
-              <a:t>Executive summary: GS AWM leads on flow growth, margin depends on the market and on the allocation lens</a:t>
+              <a:t>Executive summary: GS AWM leads on flow growth; margin hinges on markets and allocation</a:t>
             </a:r>
           </a:p>
         </p:txBody>
@@ -3262,7 +3262,7 @@
               </a:defRPr>
             </a:pPr>
             <a:r>
-              <a:t>• GCC private wealth office: illustrative NPV $184m, but 93% comes from terminal value (explicit-period NPV $14m): Monte Carlo: mean NPV $275m, 9% chance of loss; staging a pilot first was worth $-94m (negative: it delays a project that is positive in most paths).</a:t>
+              <a:t>• GCC private wealth office: illustrative NPV $184m, but 93% comes from terminal value (explicit-period NPV $14m): Monte Carlo: mean NPV $275m, 9% chance of loss; staging a pilot first was worth -$94m (negative: it delays a project that is positive in most paths).</a:t>
             </a:r>
           </a:p>
         </p:txBody>
@@ -3442,7 +3442,7 @@
               </a:defRPr>
             </a:pPr>
             <a:r>
-              <a:t>• Operating margin T4Q: GS 25.3% (as of 2026-06-30; segment pre-tax), BLK 32.5%, IVZ 15.4%, TROW 30.8%.</a:t>
+              <a:t>• Operating margin T4Q: GS 25.3% (as of 2026-06-30; segment pre-tax), BLK 32.5%, IVZ 15.4%, TROW 30.8%, JPM AWM 36.8%, MS IM 23.1%, BEN 10.9%.</a:t>
             </a:r>
           </a:p>
           <a:p>
@@ -4078,7 +4078,7 @@
               </a:defRPr>
             </a:pPr>
             <a:r>
-              <a:t>• Staged entry (pilot, expand if AUM clears $350m at year 2; 52% pass): option value $-94m, i.e. staging lowers expected value; use it only as risk control.</a:t>
+              <a:t>• Staged entry (pilot, expand if AUM clears $350m at year 2; 52% pass): option value -$94m, i.e. staging lowers expected value; use it only as risk control.</a:t>
             </a:r>
           </a:p>
           <a:p>

</xml_diff>